<commit_message>
Added more page showcases
</commit_message>
<xml_diff>
--- a/Documentation/VizsgaremekPPT.pptx
+++ b/Documentation/VizsgaremekPPT.pptx
@@ -11,6 +11,9 @@
     <p:sldId id="261" r:id="rId5"/>
     <p:sldId id="260" r:id="rId6"/>
     <p:sldId id="259" r:id="rId7"/>
+    <p:sldId id="262" r:id="rId8"/>
+    <p:sldId id="263" r:id="rId9"/>
+    <p:sldId id="264" r:id="rId10"/>
   </p:sldIdLst>
   <p:sldSz cx="12192000" cy="6858000"/>
   <p:notesSz cx="6858000" cy="9144000"/>
@@ -109,6 +112,11 @@
       </a:defRPr>
     </a:lvl9pPr>
   </p:defaultTextStyle>
+  <p:extLst>
+    <p:ext uri="{EFAFB233-063F-42B5-8137-9DF3F51BA10A}">
+      <p15:sldGuideLst xmlns:p15="http://schemas.microsoft.com/office/powerpoint/2012/main"/>
+    </p:ext>
+  </p:extLst>
 </p:presentation>
 </file>
 
@@ -169,7 +177,7 @@
           <a:noFill/>
           <a:extLst>
             <a:ext uri="{909E8E84-426E-40dd-AFC4-6F175D3DCCD1}">
-              <a14:hiddenFill xmlns:a14="http://schemas.microsoft.com/office/drawing/2010/main" xmlns="">
+              <a14:hiddenFill xmlns="" xmlns:a14="http://schemas.microsoft.com/office/drawing/2010/main">
                 <a:solidFill>
                   <a:srgbClr val="FFFFFF"/>
                 </a:solidFill>
@@ -228,7 +236,7 @@
             </a:ln>
             <a:extLst>
               <a:ext uri="{91240B29-F687-4f45-9708-019B960494DF}">
-                <a14:hiddenLine xmlns:a14="http://schemas.microsoft.com/office/drawing/2010/main" xmlns="" w="9525">
+                <a14:hiddenLine xmlns="" xmlns:a14="http://schemas.microsoft.com/office/drawing/2010/main" w="9525">
                   <a:solidFill>
                     <a:srgbClr val="000000"/>
                   </a:solidFill>
@@ -318,7 +326,7 @@
             </a:ln>
             <a:extLst>
               <a:ext uri="{91240B29-F687-4f45-9708-019B960494DF}">
-                <a14:hiddenLine xmlns:a14="http://schemas.microsoft.com/office/drawing/2010/main" xmlns="" w="9525">
+                <a14:hiddenLine xmlns="" xmlns:a14="http://schemas.microsoft.com/office/drawing/2010/main" w="9525">
                   <a:solidFill>
                     <a:srgbClr val="000000"/>
                   </a:solidFill>
@@ -408,7 +416,7 @@
             </a:ln>
             <a:extLst>
               <a:ext uri="{91240B29-F687-4f45-9708-019B960494DF}">
-                <a14:hiddenLine xmlns:a14="http://schemas.microsoft.com/office/drawing/2010/main" xmlns="" w="9525">
+                <a14:hiddenLine xmlns="" xmlns:a14="http://schemas.microsoft.com/office/drawing/2010/main" w="9525">
                   <a:solidFill>
                     <a:srgbClr val="000000"/>
                   </a:solidFill>
@@ -442,7 +450,7 @@
             </a:ln>
             <a:extLst>
               <a:ext uri="{91240B29-F687-4f45-9708-019B960494DF}">
-                <a14:hiddenLine xmlns:a14="http://schemas.microsoft.com/office/drawing/2010/main" xmlns="" w="9525">
+                <a14:hiddenLine xmlns="" xmlns:a14="http://schemas.microsoft.com/office/drawing/2010/main" w="9525">
                   <a:solidFill>
                     <a:srgbClr val="000000"/>
                   </a:solidFill>
@@ -532,7 +540,7 @@
             </a:ln>
             <a:extLst>
               <a:ext uri="{91240B29-F687-4f45-9708-019B960494DF}">
-                <a14:hiddenLine xmlns:a14="http://schemas.microsoft.com/office/drawing/2010/main" xmlns="" w="9525">
+                <a14:hiddenLine xmlns="" xmlns:a14="http://schemas.microsoft.com/office/drawing/2010/main" w="9525">
                   <a:solidFill>
                     <a:srgbClr val="000000"/>
                   </a:solidFill>
@@ -594,7 +602,7 @@
             </a:ln>
             <a:extLst>
               <a:ext uri="{91240B29-F687-4f45-9708-019B960494DF}">
-                <a14:hiddenLine xmlns:a14="http://schemas.microsoft.com/office/drawing/2010/main" xmlns="" w="9525">
+                <a14:hiddenLine xmlns="" xmlns:a14="http://schemas.microsoft.com/office/drawing/2010/main" w="9525">
                   <a:solidFill>
                     <a:srgbClr val="000000"/>
                   </a:solidFill>
@@ -656,7 +664,7 @@
             </a:ln>
             <a:extLst>
               <a:ext uri="{91240B29-F687-4f45-9708-019B960494DF}">
-                <a14:hiddenLine xmlns:a14="http://schemas.microsoft.com/office/drawing/2010/main" xmlns="" w="9525">
+                <a14:hiddenLine xmlns="" xmlns:a14="http://schemas.microsoft.com/office/drawing/2010/main" w="9525">
                   <a:solidFill>
                     <a:srgbClr val="000000"/>
                   </a:solidFill>
@@ -746,7 +754,7 @@
             </a:ln>
             <a:extLst>
               <a:ext uri="{91240B29-F687-4f45-9708-019B960494DF}">
-                <a14:hiddenLine xmlns:a14="http://schemas.microsoft.com/office/drawing/2010/main" xmlns="" w="9525">
+                <a14:hiddenLine xmlns="" xmlns:a14="http://schemas.microsoft.com/office/drawing/2010/main" w="9525">
                   <a:solidFill>
                     <a:srgbClr val="000000"/>
                   </a:solidFill>
@@ -808,7 +816,7 @@
             </a:ln>
             <a:extLst>
               <a:ext uri="{91240B29-F687-4f45-9708-019B960494DF}">
-                <a14:hiddenLine xmlns:a14="http://schemas.microsoft.com/office/drawing/2010/main" xmlns="" w="9525">
+                <a14:hiddenLine xmlns="" xmlns:a14="http://schemas.microsoft.com/office/drawing/2010/main" w="9525">
                   <a:solidFill>
                     <a:srgbClr val="000000"/>
                   </a:solidFill>
@@ -870,7 +878,7 @@
             </a:ln>
             <a:extLst>
               <a:ext uri="{91240B29-F687-4f45-9708-019B960494DF}">
-                <a14:hiddenLine xmlns:a14="http://schemas.microsoft.com/office/drawing/2010/main" xmlns="" w="9525">
+                <a14:hiddenLine xmlns="" xmlns:a14="http://schemas.microsoft.com/office/drawing/2010/main" w="9525">
                   <a:solidFill>
                     <a:srgbClr val="000000"/>
                   </a:solidFill>
@@ -960,7 +968,7 @@
             </a:ln>
             <a:extLst>
               <a:ext uri="{91240B29-F687-4f45-9708-019B960494DF}">
-                <a14:hiddenLine xmlns:a14="http://schemas.microsoft.com/office/drawing/2010/main" xmlns="" w="9525">
+                <a14:hiddenLine xmlns="" xmlns:a14="http://schemas.microsoft.com/office/drawing/2010/main" w="9525">
                   <a:solidFill>
                     <a:srgbClr val="000000"/>
                   </a:solidFill>
@@ -1050,7 +1058,7 @@
             </a:ln>
             <a:extLst>
               <a:ext uri="{91240B29-F687-4f45-9708-019B960494DF}">
-                <a14:hiddenLine xmlns:a14="http://schemas.microsoft.com/office/drawing/2010/main" xmlns="" w="9525">
+                <a14:hiddenLine xmlns="" xmlns:a14="http://schemas.microsoft.com/office/drawing/2010/main" w="9525">
                   <a:solidFill>
                     <a:srgbClr val="000000"/>
                   </a:solidFill>
@@ -1112,7 +1120,7 @@
             </a:ln>
             <a:extLst>
               <a:ext uri="{91240B29-F687-4f45-9708-019B960494DF}">
-                <a14:hiddenLine xmlns:a14="http://schemas.microsoft.com/office/drawing/2010/main" xmlns="" w="9525">
+                <a14:hiddenLine xmlns="" xmlns:a14="http://schemas.microsoft.com/office/drawing/2010/main" w="9525">
                   <a:solidFill>
                     <a:srgbClr val="000000"/>
                   </a:solidFill>
@@ -1222,7 +1230,7 @@
             </a:ln>
             <a:extLst>
               <a:ext uri="{91240B29-F687-4f45-9708-019B960494DF}">
-                <a14:hiddenLine xmlns:a14="http://schemas.microsoft.com/office/drawing/2010/main" xmlns="" w="9525">
+                <a14:hiddenLine xmlns="" xmlns:a14="http://schemas.microsoft.com/office/drawing/2010/main" w="9525">
                   <a:solidFill>
                     <a:srgbClr val="000000"/>
                   </a:solidFill>
@@ -1284,7 +1292,7 @@
             </a:ln>
             <a:extLst>
               <a:ext uri="{91240B29-F687-4f45-9708-019B960494DF}">
-                <a14:hiddenLine xmlns:a14="http://schemas.microsoft.com/office/drawing/2010/main" xmlns="" w="9525">
+                <a14:hiddenLine xmlns="" xmlns:a14="http://schemas.microsoft.com/office/drawing/2010/main" w="9525">
                   <a:solidFill>
                     <a:srgbClr val="000000"/>
                   </a:solidFill>
@@ -1374,7 +1382,7 @@
             </a:ln>
             <a:extLst>
               <a:ext uri="{91240B29-F687-4f45-9708-019B960494DF}">
-                <a14:hiddenLine xmlns:a14="http://schemas.microsoft.com/office/drawing/2010/main" xmlns="" w="9525">
+                <a14:hiddenLine xmlns="" xmlns:a14="http://schemas.microsoft.com/office/drawing/2010/main" w="9525">
                   <a:solidFill>
                     <a:srgbClr val="000000"/>
                   </a:solidFill>
@@ -1464,7 +1472,7 @@
             </a:ln>
             <a:extLst>
               <a:ext uri="{91240B29-F687-4f45-9708-019B960494DF}">
-                <a14:hiddenLine xmlns:a14="http://schemas.microsoft.com/office/drawing/2010/main" xmlns="" w="9525">
+                <a14:hiddenLine xmlns="" xmlns:a14="http://schemas.microsoft.com/office/drawing/2010/main" w="9525">
                   <a:solidFill>
                     <a:srgbClr val="000000"/>
                   </a:solidFill>
@@ -1526,7 +1534,7 @@
             </a:ln>
             <a:extLst>
               <a:ext uri="{91240B29-F687-4f45-9708-019B960494DF}">
-                <a14:hiddenLine xmlns:a14="http://schemas.microsoft.com/office/drawing/2010/main" xmlns="" w="9525">
+                <a14:hiddenLine xmlns="" xmlns:a14="http://schemas.microsoft.com/office/drawing/2010/main" w="9525">
                   <a:solidFill>
                     <a:srgbClr val="000000"/>
                   </a:solidFill>
@@ -1616,7 +1624,7 @@
             </a:ln>
             <a:extLst>
               <a:ext uri="{91240B29-F687-4f45-9708-019B960494DF}">
-                <a14:hiddenLine xmlns:a14="http://schemas.microsoft.com/office/drawing/2010/main" xmlns="" w="9525">
+                <a14:hiddenLine xmlns="" xmlns:a14="http://schemas.microsoft.com/office/drawing/2010/main" w="9525">
                   <a:solidFill>
                     <a:srgbClr val="000000"/>
                   </a:solidFill>
@@ -1706,7 +1714,7 @@
             </a:ln>
             <a:extLst>
               <a:ext uri="{91240B29-F687-4f45-9708-019B960494DF}">
-                <a14:hiddenLine xmlns:a14="http://schemas.microsoft.com/office/drawing/2010/main" xmlns="" w="9525">
+                <a14:hiddenLine xmlns="" xmlns:a14="http://schemas.microsoft.com/office/drawing/2010/main" w="9525">
                   <a:solidFill>
                     <a:srgbClr val="000000"/>
                   </a:solidFill>
@@ -1762,7 +1770,7 @@
             </a:ln>
             <a:extLst>
               <a:ext uri="{91240B29-F687-4f45-9708-019B960494DF}">
-                <a14:hiddenLine xmlns:a14="http://schemas.microsoft.com/office/drawing/2010/main" xmlns="" w="9525">
+                <a14:hiddenLine xmlns="" xmlns:a14="http://schemas.microsoft.com/office/drawing/2010/main" w="9525">
                   <a:solidFill>
                     <a:srgbClr val="000000"/>
                   </a:solidFill>
@@ -1852,7 +1860,7 @@
             </a:ln>
             <a:extLst>
               <a:ext uri="{91240B29-F687-4f45-9708-019B960494DF}">
-                <a14:hiddenLine xmlns:a14="http://schemas.microsoft.com/office/drawing/2010/main" xmlns="" w="9525">
+                <a14:hiddenLine xmlns="" xmlns:a14="http://schemas.microsoft.com/office/drawing/2010/main" w="9525">
                   <a:solidFill>
                     <a:srgbClr val="000000"/>
                   </a:solidFill>
@@ -1908,7 +1916,7 @@
             </a:ln>
             <a:extLst>
               <a:ext uri="{91240B29-F687-4f45-9708-019B960494DF}">
-                <a14:hiddenLine xmlns:a14="http://schemas.microsoft.com/office/drawing/2010/main" xmlns="" w="9525">
+                <a14:hiddenLine xmlns="" xmlns:a14="http://schemas.microsoft.com/office/drawing/2010/main" w="9525">
                   <a:solidFill>
                     <a:srgbClr val="000000"/>
                   </a:solidFill>
@@ -1998,7 +2006,7 @@
             </a:ln>
             <a:extLst>
               <a:ext uri="{91240B29-F687-4f45-9708-019B960494DF}">
-                <a14:hiddenLine xmlns:a14="http://schemas.microsoft.com/office/drawing/2010/main" xmlns="" w="9525">
+                <a14:hiddenLine xmlns="" xmlns:a14="http://schemas.microsoft.com/office/drawing/2010/main" w="9525">
                   <a:solidFill>
                     <a:srgbClr val="000000"/>
                   </a:solidFill>
@@ -2066,7 +2074,7 @@
             </a:ln>
             <a:extLst>
               <a:ext uri="{91240B29-F687-4f45-9708-019B960494DF}">
-                <a14:hiddenLine xmlns:a14="http://schemas.microsoft.com/office/drawing/2010/main" xmlns="" w="9525">
+                <a14:hiddenLine xmlns="" xmlns:a14="http://schemas.microsoft.com/office/drawing/2010/main" w="9525">
                   <a:solidFill>
                     <a:srgbClr val="000000"/>
                   </a:solidFill>
@@ -2156,7 +2164,7 @@
             </a:ln>
             <a:extLst>
               <a:ext uri="{91240B29-F687-4f45-9708-019B960494DF}">
-                <a14:hiddenLine xmlns:a14="http://schemas.microsoft.com/office/drawing/2010/main" xmlns="" w="9525">
+                <a14:hiddenLine xmlns="" xmlns:a14="http://schemas.microsoft.com/office/drawing/2010/main" w="9525">
                   <a:solidFill>
                     <a:srgbClr val="000000"/>
                   </a:solidFill>
@@ -2224,7 +2232,7 @@
             </a:ln>
             <a:extLst>
               <a:ext uri="{91240B29-F687-4f45-9708-019B960494DF}">
-                <a14:hiddenLine xmlns:a14="http://schemas.microsoft.com/office/drawing/2010/main" xmlns="" w="9525">
+                <a14:hiddenLine xmlns="" xmlns:a14="http://schemas.microsoft.com/office/drawing/2010/main" w="9525">
                   <a:solidFill>
                     <a:srgbClr val="000000"/>
                   </a:solidFill>
@@ -2314,7 +2322,7 @@
             </a:ln>
             <a:extLst>
               <a:ext uri="{91240B29-F687-4f45-9708-019B960494DF}">
-                <a14:hiddenLine xmlns:a14="http://schemas.microsoft.com/office/drawing/2010/main" xmlns="" w="9525">
+                <a14:hiddenLine xmlns="" xmlns:a14="http://schemas.microsoft.com/office/drawing/2010/main" w="9525">
                   <a:solidFill>
                     <a:srgbClr val="000000"/>
                   </a:solidFill>
@@ -2348,7 +2356,7 @@
             </a:ln>
             <a:extLst>
               <a:ext uri="{91240B29-F687-4f45-9708-019B960494DF}">
-                <a14:hiddenLine xmlns:a14="http://schemas.microsoft.com/office/drawing/2010/main" xmlns="" w="9525">
+                <a14:hiddenLine xmlns="" xmlns:a14="http://schemas.microsoft.com/office/drawing/2010/main" w="9525">
                   <a:solidFill>
                     <a:srgbClr val="000000"/>
                   </a:solidFill>
@@ -2438,7 +2446,7 @@
             </a:ln>
             <a:extLst>
               <a:ext uri="{91240B29-F687-4f45-9708-019B960494DF}">
-                <a14:hiddenLine xmlns:a14="http://schemas.microsoft.com/office/drawing/2010/main" xmlns="" w="9525">
+                <a14:hiddenLine xmlns="" xmlns:a14="http://schemas.microsoft.com/office/drawing/2010/main" w="9525">
                   <a:solidFill>
                     <a:srgbClr val="000000"/>
                   </a:solidFill>
@@ -2500,7 +2508,7 @@
             </a:ln>
             <a:extLst>
               <a:ext uri="{91240B29-F687-4f45-9708-019B960494DF}">
-                <a14:hiddenLine xmlns:a14="http://schemas.microsoft.com/office/drawing/2010/main" xmlns="" w="9525">
+                <a14:hiddenLine xmlns="" xmlns:a14="http://schemas.microsoft.com/office/drawing/2010/main" w="9525">
                   <a:solidFill>
                     <a:srgbClr val="000000"/>
                   </a:solidFill>
@@ -2562,7 +2570,7 @@
             </a:ln>
             <a:extLst>
               <a:ext uri="{91240B29-F687-4f45-9708-019B960494DF}">
-                <a14:hiddenLine xmlns:a14="http://schemas.microsoft.com/office/drawing/2010/main" xmlns="" w="9525">
+                <a14:hiddenLine xmlns="" xmlns:a14="http://schemas.microsoft.com/office/drawing/2010/main" w="9525">
                   <a:solidFill>
                     <a:srgbClr val="000000"/>
                   </a:solidFill>
@@ -2652,7 +2660,7 @@
             </a:ln>
             <a:extLst>
               <a:ext uri="{91240B29-F687-4f45-9708-019B960494DF}">
-                <a14:hiddenLine xmlns:a14="http://schemas.microsoft.com/office/drawing/2010/main" xmlns="" w="9525">
+                <a14:hiddenLine xmlns="" xmlns:a14="http://schemas.microsoft.com/office/drawing/2010/main" w="9525">
                   <a:solidFill>
                     <a:srgbClr val="000000"/>
                   </a:solidFill>
@@ -2720,7 +2728,7 @@
             </a:ln>
             <a:extLst>
               <a:ext uri="{91240B29-F687-4f45-9708-019B960494DF}">
-                <a14:hiddenLine xmlns:a14="http://schemas.microsoft.com/office/drawing/2010/main" xmlns="" w="9525">
+                <a14:hiddenLine xmlns="" xmlns:a14="http://schemas.microsoft.com/office/drawing/2010/main" w="9525">
                   <a:solidFill>
                     <a:srgbClr val="000000"/>
                   </a:solidFill>
@@ -2782,7 +2790,7 @@
             </a:ln>
             <a:extLst>
               <a:ext uri="{91240B29-F687-4f45-9708-019B960494DF}">
-                <a14:hiddenLine xmlns:a14="http://schemas.microsoft.com/office/drawing/2010/main" xmlns="" w="9525">
+                <a14:hiddenLine xmlns="" xmlns:a14="http://schemas.microsoft.com/office/drawing/2010/main" w="9525">
                   <a:solidFill>
                     <a:srgbClr val="000000"/>
                   </a:solidFill>
@@ -2872,7 +2880,7 @@
             </a:ln>
             <a:extLst>
               <a:ext uri="{91240B29-F687-4f45-9708-019B960494DF}">
-                <a14:hiddenLine xmlns:a14="http://schemas.microsoft.com/office/drawing/2010/main" xmlns="" w="9525">
+                <a14:hiddenLine xmlns="" xmlns:a14="http://schemas.microsoft.com/office/drawing/2010/main" w="9525">
                   <a:solidFill>
                     <a:srgbClr val="000000"/>
                   </a:solidFill>
@@ -2934,7 +2942,7 @@
             </a:ln>
             <a:extLst>
               <a:ext uri="{91240B29-F687-4f45-9708-019B960494DF}">
-                <a14:hiddenLine xmlns:a14="http://schemas.microsoft.com/office/drawing/2010/main" xmlns="" w="9525">
+                <a14:hiddenLine xmlns="" xmlns:a14="http://schemas.microsoft.com/office/drawing/2010/main" w="9525">
                   <a:solidFill>
                     <a:srgbClr val="000000"/>
                   </a:solidFill>
@@ -3024,7 +3032,7 @@
             </a:ln>
             <a:extLst>
               <a:ext uri="{91240B29-F687-4f45-9708-019B960494DF}">
-                <a14:hiddenLine xmlns:a14="http://schemas.microsoft.com/office/drawing/2010/main" xmlns="" w="9525">
+                <a14:hiddenLine xmlns="" xmlns:a14="http://schemas.microsoft.com/office/drawing/2010/main" w="9525">
                   <a:solidFill>
                     <a:srgbClr val="000000"/>
                   </a:solidFill>
@@ -3086,7 +3094,7 @@
             </a:ln>
             <a:extLst>
               <a:ext uri="{91240B29-F687-4f45-9708-019B960494DF}">
-                <a14:hiddenLine xmlns:a14="http://schemas.microsoft.com/office/drawing/2010/main" xmlns="" w="9525">
+                <a14:hiddenLine xmlns="" xmlns:a14="http://schemas.microsoft.com/office/drawing/2010/main" w="9525">
                   <a:solidFill>
                     <a:srgbClr val="000000"/>
                   </a:solidFill>
@@ -3176,7 +3184,7 @@
             </a:ln>
             <a:extLst>
               <a:ext uri="{91240B29-F687-4f45-9708-019B960494DF}">
-                <a14:hiddenLine xmlns:a14="http://schemas.microsoft.com/office/drawing/2010/main" xmlns="" w="9525">
+                <a14:hiddenLine xmlns="" xmlns:a14="http://schemas.microsoft.com/office/drawing/2010/main" w="9525">
                   <a:solidFill>
                     <a:srgbClr val="000000"/>
                   </a:solidFill>
@@ -3210,7 +3218,7 @@
             </a:ln>
             <a:extLst>
               <a:ext uri="{91240B29-F687-4f45-9708-019B960494DF}">
-                <a14:hiddenLine xmlns:a14="http://schemas.microsoft.com/office/drawing/2010/main" xmlns="" w="9525">
+                <a14:hiddenLine xmlns="" xmlns:a14="http://schemas.microsoft.com/office/drawing/2010/main" w="9525">
                   <a:solidFill>
                     <a:srgbClr val="000000"/>
                   </a:solidFill>
@@ -3275,7 +3283,7 @@
             </a:ln>
             <a:extLst>
               <a:ext uri="{91240B29-F687-4f45-9708-019B960494DF}">
-                <a14:hiddenLine xmlns:a14="http://schemas.microsoft.com/office/drawing/2010/main" xmlns="" w="9525">
+                <a14:hiddenLine xmlns="" xmlns:a14="http://schemas.microsoft.com/office/drawing/2010/main" w="9525">
                   <a:solidFill>
                     <a:srgbClr val="000000"/>
                   </a:solidFill>
@@ -3365,7 +3373,7 @@
             </a:ln>
             <a:extLst>
               <a:ext uri="{91240B29-F687-4f45-9708-019B960494DF}">
-                <a14:hiddenLine xmlns:a14="http://schemas.microsoft.com/office/drawing/2010/main" xmlns="" w="9525">
+                <a14:hiddenLine xmlns="" xmlns:a14="http://schemas.microsoft.com/office/drawing/2010/main" w="9525">
                   <a:solidFill>
                     <a:srgbClr val="000000"/>
                   </a:solidFill>
@@ -3427,7 +3435,7 @@
             </a:ln>
             <a:extLst>
               <a:ext uri="{91240B29-F687-4f45-9708-019B960494DF}">
-                <a14:hiddenLine xmlns:a14="http://schemas.microsoft.com/office/drawing/2010/main" xmlns="" w="9525">
+                <a14:hiddenLine xmlns="" xmlns:a14="http://schemas.microsoft.com/office/drawing/2010/main" w="9525">
                   <a:solidFill>
                     <a:srgbClr val="000000"/>
                   </a:solidFill>
@@ -3517,7 +3525,7 @@
             </a:ln>
             <a:extLst>
               <a:ext uri="{91240B29-F687-4f45-9708-019B960494DF}">
-                <a14:hiddenLine xmlns:a14="http://schemas.microsoft.com/office/drawing/2010/main" xmlns="" w="9525">
+                <a14:hiddenLine xmlns="" xmlns:a14="http://schemas.microsoft.com/office/drawing/2010/main" w="9525">
                   <a:solidFill>
                     <a:srgbClr val="000000"/>
                   </a:solidFill>
@@ -3607,7 +3615,7 @@
             </a:ln>
             <a:extLst>
               <a:ext uri="{91240B29-F687-4f45-9708-019B960494DF}">
-                <a14:hiddenLine xmlns:a14="http://schemas.microsoft.com/office/drawing/2010/main" xmlns="" w="9525">
+                <a14:hiddenLine xmlns="" xmlns:a14="http://schemas.microsoft.com/office/drawing/2010/main" w="9525">
                   <a:solidFill>
                     <a:srgbClr val="000000"/>
                   </a:solidFill>
@@ -3672,7 +3680,7 @@
             </a:ln>
             <a:extLst>
               <a:ext uri="{91240B29-F687-4f45-9708-019B960494DF}">
-                <a14:hiddenLine xmlns:a14="http://schemas.microsoft.com/office/drawing/2010/main" xmlns="" w="9525">
+                <a14:hiddenLine xmlns="" xmlns:a14="http://schemas.microsoft.com/office/drawing/2010/main" w="9525">
                   <a:solidFill>
                     <a:srgbClr val="000000"/>
                   </a:solidFill>
@@ -3734,7 +3742,7 @@
             </a:ln>
             <a:extLst>
               <a:ext uri="{91240B29-F687-4f45-9708-019B960494DF}">
-                <a14:hiddenLine xmlns:a14="http://schemas.microsoft.com/office/drawing/2010/main" xmlns="" w="9525">
+                <a14:hiddenLine xmlns="" xmlns:a14="http://schemas.microsoft.com/office/drawing/2010/main" w="9525">
                   <a:solidFill>
                     <a:srgbClr val="000000"/>
                   </a:solidFill>
@@ -3824,7 +3832,7 @@
             </a:ln>
             <a:extLst>
               <a:ext uri="{91240B29-F687-4f45-9708-019B960494DF}">
-                <a14:hiddenLine xmlns:a14="http://schemas.microsoft.com/office/drawing/2010/main" xmlns="" w="9525">
+                <a14:hiddenLine xmlns="" xmlns:a14="http://schemas.microsoft.com/office/drawing/2010/main" w="9525">
                   <a:solidFill>
                     <a:srgbClr val="000000"/>
                   </a:solidFill>
@@ -3914,7 +3922,7 @@
             </a:ln>
             <a:extLst>
               <a:ext uri="{91240B29-F687-4f45-9708-019B960494DF}">
-                <a14:hiddenLine xmlns:a14="http://schemas.microsoft.com/office/drawing/2010/main" xmlns="" w="9525">
+                <a14:hiddenLine xmlns="" xmlns:a14="http://schemas.microsoft.com/office/drawing/2010/main" w="9525">
                   <a:solidFill>
                     <a:srgbClr val="000000"/>
                   </a:solidFill>
@@ -3976,7 +3984,7 @@
             </a:ln>
             <a:extLst>
               <a:ext uri="{91240B29-F687-4f45-9708-019B960494DF}">
-                <a14:hiddenLine xmlns:a14="http://schemas.microsoft.com/office/drawing/2010/main" xmlns="" w="9525">
+                <a14:hiddenLine xmlns="" xmlns:a14="http://schemas.microsoft.com/office/drawing/2010/main" w="9525">
                   <a:solidFill>
                     <a:srgbClr val="000000"/>
                   </a:solidFill>
@@ -4096,7 +4104,7 @@
             </a:ln>
             <a:extLst>
               <a:ext uri="{91240B29-F687-4f45-9708-019B960494DF}">
-                <a14:hiddenLine xmlns:a14="http://schemas.microsoft.com/office/drawing/2010/main" xmlns="" w="9525">
+                <a14:hiddenLine xmlns="" xmlns:a14="http://schemas.microsoft.com/office/drawing/2010/main" w="9525">
                   <a:solidFill>
                     <a:srgbClr val="000000"/>
                   </a:solidFill>
@@ -4164,7 +4172,7 @@
             </a:ln>
             <a:extLst>
               <a:ext uri="{91240B29-F687-4f45-9708-019B960494DF}">
-                <a14:hiddenLine xmlns:a14="http://schemas.microsoft.com/office/drawing/2010/main" xmlns="" w="9525">
+                <a14:hiddenLine xmlns="" xmlns:a14="http://schemas.microsoft.com/office/drawing/2010/main" w="9525">
                   <a:solidFill>
                     <a:srgbClr val="000000"/>
                   </a:solidFill>
@@ -4254,7 +4262,7 @@
             </a:ln>
             <a:extLst>
               <a:ext uri="{91240B29-F687-4f45-9708-019B960494DF}">
-                <a14:hiddenLine xmlns:a14="http://schemas.microsoft.com/office/drawing/2010/main" xmlns="" w="9525">
+                <a14:hiddenLine xmlns="" xmlns:a14="http://schemas.microsoft.com/office/drawing/2010/main" w="9525">
                   <a:solidFill>
                     <a:srgbClr val="000000"/>
                   </a:solidFill>
@@ -4394,7 +4402,7 @@
           <a:p>
             <a:fld id="{48A87A34-81AB-432B-8DAE-1953F412C126}" type="datetimeFigureOut">
               <a:rPr lang="en-US" dirty="0"/>
-              <a:t>4/1/2025</a:t>
+              <a:t>4/6/2025</a:t>
             </a:fld>
             <a:endParaRPr lang="en-US" dirty="0"/>
           </a:p>
@@ -4656,7 +4664,7 @@
           <a:p>
             <a:fld id="{48A87A34-81AB-432B-8DAE-1953F412C126}" type="datetimeFigureOut">
               <a:rPr lang="en-US" dirty="0"/>
-              <a:t>4/1/2025</a:t>
+              <a:t>4/6/2025</a:t>
             </a:fld>
             <a:endParaRPr lang="en-US" dirty="0"/>
           </a:p>
@@ -4847,7 +4855,7 @@
           <a:p>
             <a:fld id="{48A87A34-81AB-432B-8DAE-1953F412C126}" type="datetimeFigureOut">
               <a:rPr lang="en-US" dirty="0"/>
-              <a:t>4/1/2025</a:t>
+              <a:t>4/6/2025</a:t>
             </a:fld>
             <a:endParaRPr lang="en-US" dirty="0"/>
           </a:p>
@@ -5105,7 +5113,7 @@
           <a:p>
             <a:fld id="{48A87A34-81AB-432B-8DAE-1953F412C126}" type="datetimeFigureOut">
               <a:rPr lang="en-US" dirty="0"/>
-              <a:t>4/1/2025</a:t>
+              <a:t>4/6/2025</a:t>
             </a:fld>
             <a:endParaRPr lang="en-US" dirty="0"/>
           </a:p>
@@ -5534,7 +5542,7 @@
           <a:p>
             <a:fld id="{48A87A34-81AB-432B-8DAE-1953F412C126}" type="datetimeFigureOut">
               <a:rPr lang="en-US" dirty="0"/>
-              <a:t>4/1/2025</a:t>
+              <a:t>4/6/2025</a:t>
             </a:fld>
             <a:endParaRPr lang="en-US" dirty="0"/>
           </a:p>
@@ -6075,7 +6083,7 @@
           <a:p>
             <a:fld id="{48A87A34-81AB-432B-8DAE-1953F412C126}" type="datetimeFigureOut">
               <a:rPr lang="en-US" dirty="0"/>
-              <a:t>4/1/2025</a:t>
+              <a:t>4/6/2025</a:t>
             </a:fld>
             <a:endParaRPr lang="en-US" dirty="0"/>
           </a:p>
@@ -6790,7 +6798,7 @@
           <a:p>
             <a:fld id="{48A87A34-81AB-432B-8DAE-1953F412C126}" type="datetimeFigureOut">
               <a:rPr lang="en-US" dirty="0"/>
-              <a:t>4/1/2025</a:t>
+              <a:t>4/6/2025</a:t>
             </a:fld>
             <a:endParaRPr lang="en-US" dirty="0"/>
           </a:p>
@@ -6955,7 +6963,7 @@
           <a:p>
             <a:fld id="{48A87A34-81AB-432B-8DAE-1953F412C126}" type="datetimeFigureOut">
               <a:rPr lang="en-US" dirty="0"/>
-              <a:t>4/1/2025</a:t>
+              <a:t>4/6/2025</a:t>
             </a:fld>
             <a:endParaRPr lang="en-US" dirty="0"/>
           </a:p>
@@ -7130,7 +7138,7 @@
           <a:p>
             <a:fld id="{48A87A34-81AB-432B-8DAE-1953F412C126}" type="datetimeFigureOut">
               <a:rPr lang="en-US" dirty="0"/>
-              <a:t>4/1/2025</a:t>
+              <a:t>4/6/2025</a:t>
             </a:fld>
             <a:endParaRPr lang="en-US" dirty="0"/>
           </a:p>
@@ -7295,7 +7303,7 @@
           <a:p>
             <a:fld id="{48A87A34-81AB-432B-8DAE-1953F412C126}" type="datetimeFigureOut">
               <a:rPr lang="en-US" dirty="0"/>
-              <a:t>4/1/2025</a:t>
+              <a:t>4/6/2025</a:t>
             </a:fld>
             <a:endParaRPr lang="en-US" dirty="0"/>
           </a:p>
@@ -7540,7 +7548,7 @@
           <a:p>
             <a:fld id="{48A87A34-81AB-432B-8DAE-1953F412C126}" type="datetimeFigureOut">
               <a:rPr lang="en-US" dirty="0"/>
-              <a:t>4/1/2025</a:t>
+              <a:t>4/6/2025</a:t>
             </a:fld>
             <a:endParaRPr lang="en-US" dirty="0"/>
           </a:p>
@@ -7767,7 +7775,7 @@
           <a:p>
             <a:fld id="{48A87A34-81AB-432B-8DAE-1953F412C126}" type="datetimeFigureOut">
               <a:rPr lang="en-US" dirty="0"/>
-              <a:t>4/1/2025</a:t>
+              <a:t>4/6/2025</a:t>
             </a:fld>
             <a:endParaRPr lang="en-US" dirty="0"/>
           </a:p>
@@ -8143,7 +8151,7 @@
           <a:p>
             <a:fld id="{48A87A34-81AB-432B-8DAE-1953F412C126}" type="datetimeFigureOut">
               <a:rPr lang="en-US" dirty="0"/>
-              <a:t>4/1/2025</a:t>
+              <a:t>4/6/2025</a:t>
             </a:fld>
             <a:endParaRPr lang="en-US" dirty="0"/>
           </a:p>
@@ -8256,7 +8264,7 @@
           <a:p>
             <a:fld id="{48A87A34-81AB-432B-8DAE-1953F412C126}" type="datetimeFigureOut">
               <a:rPr lang="en-US" dirty="0"/>
-              <a:t>4/1/2025</a:t>
+              <a:t>4/6/2025</a:t>
             </a:fld>
             <a:endParaRPr lang="en-US" dirty="0"/>
           </a:p>
@@ -8346,7 +8354,7 @@
           <a:p>
             <a:fld id="{48A87A34-81AB-432B-8DAE-1953F412C126}" type="datetimeFigureOut">
               <a:rPr lang="en-US" dirty="0"/>
-              <a:t>4/1/2025</a:t>
+              <a:t>4/6/2025</a:t>
             </a:fld>
             <a:endParaRPr lang="en-US" dirty="0"/>
           </a:p>
@@ -8590,7 +8598,7 @@
           <a:p>
             <a:fld id="{48A87A34-81AB-432B-8DAE-1953F412C126}" type="datetimeFigureOut">
               <a:rPr lang="en-US" dirty="0"/>
-              <a:t>4/1/2025</a:t>
+              <a:t>4/6/2025</a:t>
             </a:fld>
             <a:endParaRPr lang="en-US" dirty="0"/>
           </a:p>
@@ -8865,7 +8873,7 @@
           <a:p>
             <a:fld id="{48A87A34-81AB-432B-8DAE-1953F412C126}" type="datetimeFigureOut">
               <a:rPr lang="en-US" dirty="0"/>
-              <a:t>4/1/2025</a:t>
+              <a:t>4/6/2025</a:t>
             </a:fld>
             <a:endParaRPr lang="en-US" dirty="0"/>
           </a:p>
@@ -8983,7 +8991,7 @@
           <a:noFill/>
           <a:extLst>
             <a:ext uri="{909E8E84-426E-40dd-AFC4-6F175D3DCCD1}">
-              <a14:hiddenFill xmlns:a14="http://schemas.microsoft.com/office/drawing/2010/main" xmlns="">
+              <a14:hiddenFill xmlns="" xmlns:a14="http://schemas.microsoft.com/office/drawing/2010/main">
                 <a:solidFill>
                   <a:srgbClr val="FFFFFF"/>
                 </a:solidFill>
@@ -9057,7 +9065,7 @@
               </a:ln>
               <a:extLst>
                 <a:ext uri="{91240B29-F687-4f45-9708-019B960494DF}">
-                  <a14:hiddenLine xmlns:a14="http://schemas.microsoft.com/office/drawing/2010/main" xmlns="" w="9525">
+                  <a14:hiddenLine xmlns="" xmlns:a14="http://schemas.microsoft.com/office/drawing/2010/main" w="9525">
                     <a:solidFill>
                       <a:srgbClr val="000000"/>
                     </a:solidFill>
@@ -9147,7 +9155,7 @@
               </a:ln>
               <a:extLst>
                 <a:ext uri="{91240B29-F687-4f45-9708-019B960494DF}">
-                  <a14:hiddenLine xmlns:a14="http://schemas.microsoft.com/office/drawing/2010/main" xmlns="" w="9525">
+                  <a14:hiddenLine xmlns="" xmlns:a14="http://schemas.microsoft.com/office/drawing/2010/main" w="9525">
                     <a:solidFill>
                       <a:srgbClr val="000000"/>
                     </a:solidFill>
@@ -9237,7 +9245,7 @@
               </a:ln>
               <a:extLst>
                 <a:ext uri="{91240B29-F687-4f45-9708-019B960494DF}">
-                  <a14:hiddenLine xmlns:a14="http://schemas.microsoft.com/office/drawing/2010/main" xmlns="" w="9525">
+                  <a14:hiddenLine xmlns="" xmlns:a14="http://schemas.microsoft.com/office/drawing/2010/main" w="9525">
                     <a:solidFill>
                       <a:srgbClr val="000000"/>
                     </a:solidFill>
@@ -9299,7 +9307,7 @@
               </a:ln>
               <a:extLst>
                 <a:ext uri="{91240B29-F687-4f45-9708-019B960494DF}">
-                  <a14:hiddenLine xmlns:a14="http://schemas.microsoft.com/office/drawing/2010/main" xmlns="" w="9525">
+                  <a14:hiddenLine xmlns="" xmlns:a14="http://schemas.microsoft.com/office/drawing/2010/main" w="9525">
                     <a:solidFill>
                       <a:srgbClr val="000000"/>
                     </a:solidFill>
@@ -9389,7 +9397,7 @@
               </a:ln>
               <a:extLst>
                 <a:ext uri="{91240B29-F687-4f45-9708-019B960494DF}">
-                  <a14:hiddenLine xmlns:a14="http://schemas.microsoft.com/office/drawing/2010/main" xmlns="" w="9525">
+                  <a14:hiddenLine xmlns="" xmlns:a14="http://schemas.microsoft.com/office/drawing/2010/main" w="9525">
                     <a:solidFill>
                       <a:srgbClr val="000000"/>
                     </a:solidFill>
@@ -9451,7 +9459,7 @@
               </a:ln>
               <a:extLst>
                 <a:ext uri="{91240B29-F687-4f45-9708-019B960494DF}">
-                  <a14:hiddenLine xmlns:a14="http://schemas.microsoft.com/office/drawing/2010/main" xmlns="" w="9525">
+                  <a14:hiddenLine xmlns="" xmlns:a14="http://schemas.microsoft.com/office/drawing/2010/main" w="9525">
                     <a:solidFill>
                       <a:srgbClr val="000000"/>
                     </a:solidFill>
@@ -9513,7 +9521,7 @@
               </a:ln>
               <a:extLst>
                 <a:ext uri="{91240B29-F687-4f45-9708-019B960494DF}">
-                  <a14:hiddenLine xmlns:a14="http://schemas.microsoft.com/office/drawing/2010/main" xmlns="" w="9525">
+                  <a14:hiddenLine xmlns="" xmlns:a14="http://schemas.microsoft.com/office/drawing/2010/main" w="9525">
                     <a:solidFill>
                       <a:srgbClr val="000000"/>
                     </a:solidFill>
@@ -9603,7 +9611,7 @@
               </a:ln>
               <a:extLst>
                 <a:ext uri="{91240B29-F687-4f45-9708-019B960494DF}">
-                  <a14:hiddenLine xmlns:a14="http://schemas.microsoft.com/office/drawing/2010/main" xmlns="" w="9525">
+                  <a14:hiddenLine xmlns="" xmlns:a14="http://schemas.microsoft.com/office/drawing/2010/main" w="9525">
                     <a:solidFill>
                       <a:srgbClr val="000000"/>
                     </a:solidFill>
@@ -9693,7 +9701,7 @@
               </a:ln>
               <a:extLst>
                 <a:ext uri="{91240B29-F687-4f45-9708-019B960494DF}">
-                  <a14:hiddenLine xmlns:a14="http://schemas.microsoft.com/office/drawing/2010/main" xmlns="" w="9525">
+                  <a14:hiddenLine xmlns="" xmlns:a14="http://schemas.microsoft.com/office/drawing/2010/main" w="9525">
                     <a:solidFill>
                       <a:srgbClr val="000000"/>
                     </a:solidFill>
@@ -9755,7 +9763,7 @@
               </a:ln>
               <a:extLst>
                 <a:ext uri="{91240B29-F687-4f45-9708-019B960494DF}">
-                  <a14:hiddenLine xmlns:a14="http://schemas.microsoft.com/office/drawing/2010/main" xmlns="" w="9525">
+                  <a14:hiddenLine xmlns="" xmlns:a14="http://schemas.microsoft.com/office/drawing/2010/main" w="9525">
                     <a:solidFill>
                       <a:srgbClr val="000000"/>
                     </a:solidFill>
@@ -9865,7 +9873,7 @@
               </a:ln>
               <a:extLst>
                 <a:ext uri="{91240B29-F687-4f45-9708-019B960494DF}">
-                  <a14:hiddenLine xmlns:a14="http://schemas.microsoft.com/office/drawing/2010/main" xmlns="" w="9525">
+                  <a14:hiddenLine xmlns="" xmlns:a14="http://schemas.microsoft.com/office/drawing/2010/main" w="9525">
                     <a:solidFill>
                       <a:srgbClr val="000000"/>
                     </a:solidFill>
@@ -9949,7 +9957,7 @@
               </a:ln>
               <a:extLst>
                 <a:ext uri="{91240B29-F687-4f45-9708-019B960494DF}">
-                  <a14:hiddenLine xmlns:a14="http://schemas.microsoft.com/office/drawing/2010/main" xmlns="" w="9525">
+                  <a14:hiddenLine xmlns="" xmlns:a14="http://schemas.microsoft.com/office/drawing/2010/main" w="9525">
                     <a:solidFill>
                       <a:srgbClr val="000000"/>
                     </a:solidFill>
@@ -10011,7 +10019,7 @@
               </a:ln>
               <a:extLst>
                 <a:ext uri="{91240B29-F687-4f45-9708-019B960494DF}">
-                  <a14:hiddenLine xmlns:a14="http://schemas.microsoft.com/office/drawing/2010/main" xmlns="" w="9525">
+                  <a14:hiddenLine xmlns="" xmlns:a14="http://schemas.microsoft.com/office/drawing/2010/main" w="9525">
                     <a:solidFill>
                       <a:srgbClr val="000000"/>
                     </a:solidFill>
@@ -10073,7 +10081,7 @@
               </a:ln>
               <a:extLst>
                 <a:ext uri="{91240B29-F687-4f45-9708-019B960494DF}">
-                  <a14:hiddenLine xmlns:a14="http://schemas.microsoft.com/office/drawing/2010/main" xmlns="" w="9525">
+                  <a14:hiddenLine xmlns="" xmlns:a14="http://schemas.microsoft.com/office/drawing/2010/main" w="9525">
                     <a:solidFill>
                       <a:srgbClr val="000000"/>
                     </a:solidFill>
@@ -10163,7 +10171,7 @@
               </a:ln>
               <a:extLst>
                 <a:ext uri="{91240B29-F687-4f45-9708-019B960494DF}">
-                  <a14:hiddenLine xmlns:a14="http://schemas.microsoft.com/office/drawing/2010/main" xmlns="" w="9525">
+                  <a14:hiddenLine xmlns="" xmlns:a14="http://schemas.microsoft.com/office/drawing/2010/main" w="9525">
                     <a:solidFill>
                       <a:srgbClr val="000000"/>
                     </a:solidFill>
@@ -10197,7 +10205,7 @@
               </a:ln>
               <a:extLst>
                 <a:ext uri="{91240B29-F687-4f45-9708-019B960494DF}">
-                  <a14:hiddenLine xmlns:a14="http://schemas.microsoft.com/office/drawing/2010/main" xmlns="" w="9525">
+                  <a14:hiddenLine xmlns="" xmlns:a14="http://schemas.microsoft.com/office/drawing/2010/main" w="9525">
                     <a:solidFill>
                       <a:srgbClr val="000000"/>
                     </a:solidFill>
@@ -10262,7 +10270,7 @@
               </a:ln>
               <a:extLst>
                 <a:ext uri="{91240B29-F687-4f45-9708-019B960494DF}">
-                  <a14:hiddenLine xmlns:a14="http://schemas.microsoft.com/office/drawing/2010/main" xmlns="" w="9525">
+                  <a14:hiddenLine xmlns="" xmlns:a14="http://schemas.microsoft.com/office/drawing/2010/main" w="9525">
                     <a:solidFill>
                       <a:srgbClr val="000000"/>
                     </a:solidFill>
@@ -10352,7 +10360,7 @@
               </a:ln>
               <a:extLst>
                 <a:ext uri="{91240B29-F687-4f45-9708-019B960494DF}">
-                  <a14:hiddenLine xmlns:a14="http://schemas.microsoft.com/office/drawing/2010/main" xmlns="" w="9525">
+                  <a14:hiddenLine xmlns="" xmlns:a14="http://schemas.microsoft.com/office/drawing/2010/main" w="9525">
                     <a:solidFill>
                       <a:srgbClr val="000000"/>
                     </a:solidFill>
@@ -10414,7 +10422,7 @@
               </a:ln>
               <a:extLst>
                 <a:ext uri="{91240B29-F687-4f45-9708-019B960494DF}">
-                  <a14:hiddenLine xmlns:a14="http://schemas.microsoft.com/office/drawing/2010/main" xmlns="" w="9525">
+                  <a14:hiddenLine xmlns="" xmlns:a14="http://schemas.microsoft.com/office/drawing/2010/main" w="9525">
                     <a:solidFill>
                       <a:srgbClr val="000000"/>
                     </a:solidFill>
@@ -10504,7 +10512,7 @@
               </a:ln>
               <a:extLst>
                 <a:ext uri="{91240B29-F687-4f45-9708-019B960494DF}">
-                  <a14:hiddenLine xmlns:a14="http://schemas.microsoft.com/office/drawing/2010/main" xmlns="" w="9525">
+                  <a14:hiddenLine xmlns="" xmlns:a14="http://schemas.microsoft.com/office/drawing/2010/main" w="9525">
                     <a:solidFill>
                       <a:srgbClr val="000000"/>
                     </a:solidFill>
@@ -10569,7 +10577,7 @@
               </a:ln>
               <a:extLst>
                 <a:ext uri="{91240B29-F687-4f45-9708-019B960494DF}">
-                  <a14:hiddenLine xmlns:a14="http://schemas.microsoft.com/office/drawing/2010/main" xmlns="" w="9525">
+                  <a14:hiddenLine xmlns="" xmlns:a14="http://schemas.microsoft.com/office/drawing/2010/main" w="9525">
                     <a:solidFill>
                       <a:srgbClr val="000000"/>
                     </a:solidFill>
@@ -10631,7 +10639,7 @@
               </a:ln>
               <a:extLst>
                 <a:ext uri="{91240B29-F687-4f45-9708-019B960494DF}">
-                  <a14:hiddenLine xmlns:a14="http://schemas.microsoft.com/office/drawing/2010/main" xmlns="" w="9525">
+                  <a14:hiddenLine xmlns="" xmlns:a14="http://schemas.microsoft.com/office/drawing/2010/main" w="9525">
                     <a:solidFill>
                       <a:srgbClr val="000000"/>
                     </a:solidFill>
@@ -10721,7 +10729,7 @@
               </a:ln>
               <a:extLst>
                 <a:ext uri="{91240B29-F687-4f45-9708-019B960494DF}">
-                  <a14:hiddenLine xmlns:a14="http://schemas.microsoft.com/office/drawing/2010/main" xmlns="" w="9525">
+                  <a14:hiddenLine xmlns="" xmlns:a14="http://schemas.microsoft.com/office/drawing/2010/main" w="9525">
                     <a:solidFill>
                       <a:srgbClr val="000000"/>
                     </a:solidFill>
@@ -10811,7 +10819,7 @@
               </a:ln>
               <a:extLst>
                 <a:ext uri="{91240B29-F687-4f45-9708-019B960494DF}">
-                  <a14:hiddenLine xmlns:a14="http://schemas.microsoft.com/office/drawing/2010/main" xmlns="" w="9525">
+                  <a14:hiddenLine xmlns="" xmlns:a14="http://schemas.microsoft.com/office/drawing/2010/main" w="9525">
                     <a:solidFill>
                       <a:srgbClr val="000000"/>
                     </a:solidFill>
@@ -10876,7 +10884,7 @@
               </a:ln>
               <a:extLst>
                 <a:ext uri="{91240B29-F687-4f45-9708-019B960494DF}">
-                  <a14:hiddenLine xmlns:a14="http://schemas.microsoft.com/office/drawing/2010/main" xmlns="" w="9525">
+                  <a14:hiddenLine xmlns="" xmlns:a14="http://schemas.microsoft.com/office/drawing/2010/main" w="9525">
                     <a:solidFill>
                       <a:srgbClr val="000000"/>
                     </a:solidFill>
@@ -10996,7 +11004,7 @@
               </a:ln>
               <a:extLst>
                 <a:ext uri="{91240B29-F687-4f45-9708-019B960494DF}">
-                  <a14:hiddenLine xmlns:a14="http://schemas.microsoft.com/office/drawing/2010/main" xmlns="" w="9525">
+                  <a14:hiddenLine xmlns="" xmlns:a14="http://schemas.microsoft.com/office/drawing/2010/main" w="9525">
                     <a:solidFill>
                       <a:srgbClr val="000000"/>
                     </a:solidFill>
@@ -11077,7 +11085,7 @@
               </a:ln>
               <a:extLst>
                 <a:ext uri="{91240B29-F687-4f45-9708-019B960494DF}">
-                  <a14:hiddenLine xmlns:a14="http://schemas.microsoft.com/office/drawing/2010/main" xmlns="" w="9525">
+                  <a14:hiddenLine xmlns="" xmlns:a14="http://schemas.microsoft.com/office/drawing/2010/main" w="9525">
                     <a:solidFill>
                       <a:srgbClr val="000000"/>
                     </a:solidFill>
@@ -11192,7 +11200,7 @@
               </a:ln>
               <a:extLst>
                 <a:ext uri="{91240B29-F687-4f45-9708-019B960494DF}">
-                  <a14:hiddenLine xmlns:a14="http://schemas.microsoft.com/office/drawing/2010/main" xmlns="" w="9525">
+                  <a14:hiddenLine xmlns="" xmlns:a14="http://schemas.microsoft.com/office/drawing/2010/main" w="9525">
                     <a:solidFill>
                       <a:srgbClr val="000000"/>
                     </a:solidFill>
@@ -11282,7 +11290,7 @@
               </a:ln>
               <a:extLst>
                 <a:ext uri="{91240B29-F687-4f45-9708-019B960494DF}">
-                  <a14:hiddenLine xmlns:a14="http://schemas.microsoft.com/office/drawing/2010/main" xmlns="" w="9525">
+                  <a14:hiddenLine xmlns="" xmlns:a14="http://schemas.microsoft.com/office/drawing/2010/main" w="9525">
                     <a:solidFill>
                       <a:srgbClr val="000000"/>
                     </a:solidFill>
@@ -11347,7 +11355,7 @@
               </a:ln>
               <a:extLst>
                 <a:ext uri="{91240B29-F687-4f45-9708-019B960494DF}">
-                  <a14:hiddenLine xmlns:a14="http://schemas.microsoft.com/office/drawing/2010/main" xmlns="" w="9525">
+                  <a14:hiddenLine xmlns="" xmlns:a14="http://schemas.microsoft.com/office/drawing/2010/main" w="9525">
                     <a:solidFill>
                       <a:srgbClr val="000000"/>
                     </a:solidFill>
@@ -11437,7 +11445,7 @@
               </a:ln>
               <a:extLst>
                 <a:ext uri="{91240B29-F687-4f45-9708-019B960494DF}">
-                  <a14:hiddenLine xmlns:a14="http://schemas.microsoft.com/office/drawing/2010/main" xmlns="" w="9525">
+                  <a14:hiddenLine xmlns="" xmlns:a14="http://schemas.microsoft.com/office/drawing/2010/main" w="9525">
                     <a:solidFill>
                       <a:srgbClr val="000000"/>
                     </a:solidFill>
@@ -11505,7 +11513,7 @@
               </a:ln>
               <a:extLst>
                 <a:ext uri="{91240B29-F687-4f45-9708-019B960494DF}">
-                  <a14:hiddenLine xmlns:a14="http://schemas.microsoft.com/office/drawing/2010/main" xmlns="" w="9525">
+                  <a14:hiddenLine xmlns="" xmlns:a14="http://schemas.microsoft.com/office/drawing/2010/main" w="9525">
                     <a:solidFill>
                       <a:srgbClr val="000000"/>
                     </a:solidFill>
@@ -11595,7 +11603,7 @@
               </a:ln>
               <a:extLst>
                 <a:ext uri="{91240B29-F687-4f45-9708-019B960494DF}">
-                  <a14:hiddenLine xmlns:a14="http://schemas.microsoft.com/office/drawing/2010/main" xmlns="" w="9525">
+                  <a14:hiddenLine xmlns="" xmlns:a14="http://schemas.microsoft.com/office/drawing/2010/main" w="9525">
                     <a:solidFill>
                       <a:srgbClr val="000000"/>
                     </a:solidFill>
@@ -11663,7 +11671,7 @@
               </a:ln>
               <a:extLst>
                 <a:ext uri="{91240B29-F687-4f45-9708-019B960494DF}">
-                  <a14:hiddenLine xmlns:a14="http://schemas.microsoft.com/office/drawing/2010/main" xmlns="" w="9525">
+                  <a14:hiddenLine xmlns="" xmlns:a14="http://schemas.microsoft.com/office/drawing/2010/main" w="9525">
                     <a:solidFill>
                       <a:srgbClr val="000000"/>
                     </a:solidFill>
@@ -11753,7 +11761,7 @@
               </a:ln>
               <a:extLst>
                 <a:ext uri="{91240B29-F687-4f45-9708-019B960494DF}">
-                  <a14:hiddenLine xmlns:a14="http://schemas.microsoft.com/office/drawing/2010/main" xmlns="" w="9525">
+                  <a14:hiddenLine xmlns="" xmlns:a14="http://schemas.microsoft.com/office/drawing/2010/main" w="9525">
                     <a:solidFill>
                       <a:srgbClr val="000000"/>
                     </a:solidFill>
@@ -11787,7 +11795,7 @@
               </a:ln>
               <a:extLst>
                 <a:ext uri="{91240B29-F687-4f45-9708-019B960494DF}">
-                  <a14:hiddenLine xmlns:a14="http://schemas.microsoft.com/office/drawing/2010/main" xmlns="" w="9525">
+                  <a14:hiddenLine xmlns="" xmlns:a14="http://schemas.microsoft.com/office/drawing/2010/main" w="9525">
                     <a:solidFill>
                       <a:srgbClr val="000000"/>
                     </a:solidFill>
@@ -11928,7 +11936,7 @@
             <a:fld id="{48A87A34-81AB-432B-8DAE-1953F412C126}" type="datetimeFigureOut">
               <a:rPr lang="en-US" dirty="0"/>
               <a:pPr/>
-              <a:t>4/1/2025</a:t>
+              <a:t>4/6/2025</a:t>
             </a:fld>
             <a:endParaRPr lang="en-US" dirty="0"/>
           </a:p>
@@ -12349,7 +12357,7 @@
           <p:cNvPr id="2" name="Cím 1">
             <a:extLst>
               <a:ext uri="{FF2B5EF4-FFF2-40B4-BE49-F238E27FC236}">
-                <a16:creationId xmlns:a16="http://schemas.microsoft.com/office/drawing/2014/main" id="{BE4289E4-0D87-4854-B07A-471834ADFEC2}"/>
+                <a16:creationId xmlns:a16="http://schemas.microsoft.com/office/drawing/2014/main" xmlns="" id="{BE4289E4-0D87-4854-B07A-471834ADFEC2}"/>
               </a:ext>
             </a:extLst>
           </p:cNvPr>
@@ -12377,7 +12385,7 @@
           <p:cNvPr id="3" name="Alcím 2">
             <a:extLst>
               <a:ext uri="{FF2B5EF4-FFF2-40B4-BE49-F238E27FC236}">
-                <a16:creationId xmlns:a16="http://schemas.microsoft.com/office/drawing/2014/main" id="{37BEB9E8-6E87-4AEF-8172-40D34A7B5C24}"/>
+                <a16:creationId xmlns:a16="http://schemas.microsoft.com/office/drawing/2014/main" xmlns="" id="{37BEB9E8-6E87-4AEF-8172-40D34A7B5C24}"/>
               </a:ext>
             </a:extLst>
           </p:cNvPr>
@@ -12462,7 +12470,7 @@
           <p:cNvPr id="2" name="Cím 1">
             <a:extLst>
               <a:ext uri="{FF2B5EF4-FFF2-40B4-BE49-F238E27FC236}">
-                <a16:creationId xmlns:a16="http://schemas.microsoft.com/office/drawing/2014/main" id="{8E961634-9BD6-4930-8B40-9257A3BEEB4F}"/>
+                <a16:creationId xmlns:a16="http://schemas.microsoft.com/office/drawing/2014/main" xmlns="" id="{8E961634-9BD6-4930-8B40-9257A3BEEB4F}"/>
               </a:ext>
             </a:extLst>
           </p:cNvPr>
@@ -12498,7 +12506,7 @@
           <p:cNvPr id="3" name="Tartalom helye 2">
             <a:extLst>
               <a:ext uri="{FF2B5EF4-FFF2-40B4-BE49-F238E27FC236}">
-                <a16:creationId xmlns:a16="http://schemas.microsoft.com/office/drawing/2014/main" id="{B2BBCEB5-1024-4A82-A679-2EC2DDDC94AB}"/>
+                <a16:creationId xmlns:a16="http://schemas.microsoft.com/office/drawing/2014/main" xmlns="" id="{B2BBCEB5-1024-4A82-A679-2EC2DDDC94AB}"/>
               </a:ext>
             </a:extLst>
           </p:cNvPr>
@@ -12556,7 +12564,7 @@
           <p:cNvPr id="2" name="Cím 1">
             <a:extLst>
               <a:ext uri="{FF2B5EF4-FFF2-40B4-BE49-F238E27FC236}">
-                <a16:creationId xmlns:a16="http://schemas.microsoft.com/office/drawing/2014/main" id="{5BCDFA6D-9D3A-4841-A026-AA75AD074972}"/>
+                <a16:creationId xmlns:a16="http://schemas.microsoft.com/office/drawing/2014/main" xmlns="" id="{5BCDFA6D-9D3A-4841-A026-AA75AD074972}"/>
               </a:ext>
             </a:extLst>
           </p:cNvPr>
@@ -12584,7 +12592,7 @@
           <p:cNvPr id="3" name="Tartalom helye 2">
             <a:extLst>
               <a:ext uri="{FF2B5EF4-FFF2-40B4-BE49-F238E27FC236}">
-                <a16:creationId xmlns:a16="http://schemas.microsoft.com/office/drawing/2014/main" id="{BC334BA2-25C3-47D2-8BF1-1972D7B40460}"/>
+                <a16:creationId xmlns:a16="http://schemas.microsoft.com/office/drawing/2014/main" xmlns="" id="{BC334BA2-25C3-47D2-8BF1-1972D7B40460}"/>
               </a:ext>
             </a:extLst>
           </p:cNvPr>
@@ -12632,7 +12640,7 @@
           <p:cNvPr id="4" name="Kép 3">
             <a:extLst>
               <a:ext uri="{FF2B5EF4-FFF2-40B4-BE49-F238E27FC236}">
-                <a16:creationId xmlns:a16="http://schemas.microsoft.com/office/drawing/2014/main" id="{925E7347-2FA2-425B-BF08-9A223A2DF567}"/>
+                <a16:creationId xmlns:a16="http://schemas.microsoft.com/office/drawing/2014/main" xmlns="" id="{925E7347-2FA2-425B-BF08-9A223A2DF567}"/>
               </a:ext>
             </a:extLst>
           </p:cNvPr>
@@ -12692,7 +12700,7 @@
           <p:cNvPr id="2" name="Cím 1">
             <a:extLst>
               <a:ext uri="{FF2B5EF4-FFF2-40B4-BE49-F238E27FC236}">
-                <a16:creationId xmlns:a16="http://schemas.microsoft.com/office/drawing/2014/main" id="{9BA603C3-316B-415F-BAE6-007011CBDC13}"/>
+                <a16:creationId xmlns:a16="http://schemas.microsoft.com/office/drawing/2014/main" xmlns="" id="{9BA603C3-316B-415F-BAE6-007011CBDC13}"/>
               </a:ext>
             </a:extLst>
           </p:cNvPr>
@@ -12703,7 +12711,12 @@
             <p:ph type="title"/>
           </p:nvPr>
         </p:nvSpPr>
-        <p:spPr/>
+        <p:spPr>
+          <a:xfrm>
+            <a:off x="1062026" y="456472"/>
+            <a:ext cx="9905998" cy="1478570"/>
+          </a:xfrm>
+        </p:spPr>
         <p:txBody>
           <a:bodyPr/>
           <a:lstStyle/>
@@ -12720,7 +12733,7 @@
           <p:cNvPr id="4" name="Tartalom helye 3">
             <a:extLst>
               <a:ext uri="{FF2B5EF4-FFF2-40B4-BE49-F238E27FC236}">
-                <a16:creationId xmlns:a16="http://schemas.microsoft.com/office/drawing/2014/main" id="{F6AA71A4-B937-4C6B-B2CE-0E20881A7306}"/>
+                <a16:creationId xmlns:a16="http://schemas.microsoft.com/office/drawing/2014/main" xmlns="" id="{F6AA71A4-B937-4C6B-B2CE-0E20881A7306}"/>
               </a:ext>
             </a:extLst>
           </p:cNvPr>
@@ -12752,7 +12765,7 @@
           <p:cNvPr id="5" name="Kép 4">
             <a:extLst>
               <a:ext uri="{FF2B5EF4-FFF2-40B4-BE49-F238E27FC236}">
-                <a16:creationId xmlns:a16="http://schemas.microsoft.com/office/drawing/2014/main" id="{F61D4094-4987-4204-9B0A-5BF7E6B9D8FD}"/>
+                <a16:creationId xmlns:a16="http://schemas.microsoft.com/office/drawing/2014/main" xmlns="" id="{F61D4094-4987-4204-9B0A-5BF7E6B9D8FD}"/>
               </a:ext>
             </a:extLst>
           </p:cNvPr>
@@ -12777,6 +12790,44 @@
           </a:prstGeom>
         </p:spPr>
       </p:pic>
+      <p:sp>
+        <p:nvSpPr>
+          <p:cNvPr id="6" name="Szövegdoboz 5"/>
+          <p:cNvSpPr txBox="1"/>
+          <p:nvPr/>
+        </p:nvSpPr>
+        <p:spPr>
+          <a:xfrm>
+            <a:off x="1058966" y="1935042"/>
+            <a:ext cx="10804967" cy="461665"/>
+          </a:xfrm>
+          <a:prstGeom prst="rect">
+            <a:avLst/>
+          </a:prstGeom>
+          <a:noFill/>
+        </p:spPr>
+        <p:txBody>
+          <a:bodyPr wrap="square" rtlCol="0">
+            <a:spAutoFit/>
+          </a:bodyPr>
+          <a:lstStyle/>
+          <a:p>
+            <a:r>
+              <a:rPr lang="hu-HU" sz="2400" dirty="0" smtClean="0"/>
+              <a:t>A jelszót minden esetben </a:t>
+            </a:r>
+            <a:r>
+              <a:rPr lang="hu-HU" sz="2400" dirty="0" err="1" smtClean="0"/>
+              <a:t>hashelve</a:t>
+            </a:r>
+            <a:r>
+              <a:rPr lang="hu-HU" sz="2400" dirty="0" smtClean="0"/>
+              <a:t> kezeljük és tároljuk</a:t>
+            </a:r>
+            <a:endParaRPr lang="hu-HU" sz="2400" dirty="0"/>
+          </a:p>
+        </p:txBody>
+      </p:sp>
     </p:spTree>
     <p:extLst>
       <p:ext uri="{BB962C8B-B14F-4D97-AF65-F5344CB8AC3E}">
@@ -12812,7 +12863,7 @@
           <p:cNvPr id="2" name="Cím 1">
             <a:extLst>
               <a:ext uri="{FF2B5EF4-FFF2-40B4-BE49-F238E27FC236}">
-                <a16:creationId xmlns:a16="http://schemas.microsoft.com/office/drawing/2014/main" id="{0B4A5AE5-1282-4254-90B8-66333BE69BCA}"/>
+                <a16:creationId xmlns:a16="http://schemas.microsoft.com/office/drawing/2014/main" xmlns="" id="{0B4A5AE5-1282-4254-90B8-66333BE69BCA}"/>
               </a:ext>
             </a:extLst>
           </p:cNvPr>
@@ -12840,7 +12891,7 @@
           <p:cNvPr id="3" name="Tartalom helye 2">
             <a:extLst>
               <a:ext uri="{FF2B5EF4-FFF2-40B4-BE49-F238E27FC236}">
-                <a16:creationId xmlns:a16="http://schemas.microsoft.com/office/drawing/2014/main" id="{4DAAC951-F547-44F2-B289-B376D97EE48E}"/>
+                <a16:creationId xmlns:a16="http://schemas.microsoft.com/office/drawing/2014/main" xmlns="" id="{4DAAC951-F547-44F2-B289-B376D97EE48E}"/>
               </a:ext>
             </a:extLst>
           </p:cNvPr>
@@ -12894,7 +12945,7 @@
           <p:cNvPr id="5" name="Kép 4">
             <a:extLst>
               <a:ext uri="{FF2B5EF4-FFF2-40B4-BE49-F238E27FC236}">
-                <a16:creationId xmlns:a16="http://schemas.microsoft.com/office/drawing/2014/main" id="{964D5808-8D35-47A9-8C45-6BEB933E57E2}"/>
+                <a16:creationId xmlns:a16="http://schemas.microsoft.com/office/drawing/2014/main" xmlns="" id="{964D5808-8D35-47A9-8C45-6BEB933E57E2}"/>
               </a:ext>
             </a:extLst>
           </p:cNvPr>
@@ -12954,7 +13005,7 @@
           <p:cNvPr id="2" name="Cím 1">
             <a:extLst>
               <a:ext uri="{FF2B5EF4-FFF2-40B4-BE49-F238E27FC236}">
-                <a16:creationId xmlns:a16="http://schemas.microsoft.com/office/drawing/2014/main" id="{7FAD7E1E-A3C7-4EC1-B014-F018282F2DE6}"/>
+                <a16:creationId xmlns:a16="http://schemas.microsoft.com/office/drawing/2014/main" xmlns="" id="{7FAD7E1E-A3C7-4EC1-B014-F018282F2DE6}"/>
               </a:ext>
             </a:extLst>
           </p:cNvPr>
@@ -12982,7 +13033,7 @@
           <p:cNvPr id="3" name="Tartalom helye 2">
             <a:extLst>
               <a:ext uri="{FF2B5EF4-FFF2-40B4-BE49-F238E27FC236}">
-                <a16:creationId xmlns:a16="http://schemas.microsoft.com/office/drawing/2014/main" id="{F917F852-2C41-4786-B3B9-1145C1E3821C}"/>
+                <a16:creationId xmlns:a16="http://schemas.microsoft.com/office/drawing/2014/main" xmlns="" id="{F917F852-2C41-4786-B3B9-1145C1E3821C}"/>
               </a:ext>
             </a:extLst>
           </p:cNvPr>
@@ -13010,7 +13061,7 @@
           <p:cNvPr id="4" name="Kép 3">
             <a:extLst>
               <a:ext uri="{FF2B5EF4-FFF2-40B4-BE49-F238E27FC236}">
-                <a16:creationId xmlns:a16="http://schemas.microsoft.com/office/drawing/2014/main" id="{38B7552B-2E43-4441-B7A3-A2E05D937A30}"/>
+                <a16:creationId xmlns:a16="http://schemas.microsoft.com/office/drawing/2014/main" xmlns="" id="{38B7552B-2E43-4441-B7A3-A2E05D937A30}"/>
               </a:ext>
             </a:extLst>
           </p:cNvPr>
@@ -13039,6 +13090,362 @@
     <p:extLst>
       <p:ext uri="{BB962C8B-B14F-4D97-AF65-F5344CB8AC3E}">
         <p14:creationId xmlns:p14="http://schemas.microsoft.com/office/powerpoint/2010/main" val="556418029"/>
+      </p:ext>
+    </p:extLst>
+  </p:cSld>
+  <p:clrMapOvr>
+    <a:masterClrMapping/>
+  </p:clrMapOvr>
+</p:sld>
+</file>
+
+<file path=ppt/slides/slide7.xml><?xml version="1.0" encoding="utf-8"?>
+<p:sld xmlns:a="http://schemas.openxmlformats.org/drawingml/2006/main" xmlns:r="http://schemas.openxmlformats.org/officeDocument/2006/relationships" xmlns:p="http://schemas.openxmlformats.org/presentationml/2006/main">
+  <p:cSld>
+    <p:spTree>
+      <p:nvGrpSpPr>
+        <p:cNvPr id="1" name=""/>
+        <p:cNvGrpSpPr/>
+        <p:nvPr/>
+      </p:nvGrpSpPr>
+      <p:grpSpPr>
+        <a:xfrm>
+          <a:off x="0" y="0"/>
+          <a:ext cx="0" cy="0"/>
+          <a:chOff x="0" y="0"/>
+          <a:chExt cx="0" cy="0"/>
+        </a:xfrm>
+      </p:grpSpPr>
+      <p:sp>
+        <p:nvSpPr>
+          <p:cNvPr id="2" name="Cím 1"/>
+          <p:cNvSpPr>
+            <a:spLocks noGrp="1"/>
+          </p:cNvSpPr>
+          <p:nvPr>
+            <p:ph type="title"/>
+          </p:nvPr>
+        </p:nvSpPr>
+        <p:spPr/>
+        <p:txBody>
+          <a:bodyPr/>
+          <a:lstStyle/>
+          <a:p>
+            <a:r>
+              <a:rPr lang="hu-HU" dirty="0" smtClean="0"/>
+              <a:t>Szolgáltatások létrehozása</a:t>
+            </a:r>
+            <a:endParaRPr lang="hu-HU" dirty="0"/>
+          </a:p>
+        </p:txBody>
+      </p:sp>
+      <p:sp>
+        <p:nvSpPr>
+          <p:cNvPr id="3" name="Tartalom helye 2"/>
+          <p:cNvSpPr>
+            <a:spLocks noGrp="1"/>
+          </p:cNvSpPr>
+          <p:nvPr>
+            <p:ph idx="1"/>
+          </p:nvPr>
+        </p:nvSpPr>
+        <p:spPr/>
+        <p:txBody>
+          <a:bodyPr/>
+          <a:lstStyle/>
+          <a:p>
+            <a:r>
+              <a:rPr lang="hu-HU" dirty="0" smtClean="0"/>
+              <a:t>Erről az oldalról posztolhatunk új szolgáltatást a szükséges mezők kitöltését követően.</a:t>
+            </a:r>
+            <a:endParaRPr lang="hu-HU" dirty="0"/>
+          </a:p>
+        </p:txBody>
+      </p:sp>
+      <p:pic>
+        <p:nvPicPr>
+          <p:cNvPr id="4" name="Kép 3"/>
+          <p:cNvPicPr>
+            <a:picLocks noChangeAspect="1"/>
+          </p:cNvPicPr>
+          <p:nvPr/>
+        </p:nvPicPr>
+        <p:blipFill>
+          <a:blip r:embed="rId2"/>
+          <a:stretch>
+            <a:fillRect/>
+          </a:stretch>
+        </p:blipFill>
+        <p:spPr>
+          <a:xfrm>
+            <a:off x="4386805" y="3492882"/>
+            <a:ext cx="5299111" cy="2769426"/>
+          </a:xfrm>
+          <a:prstGeom prst="rect">
+            <a:avLst/>
+          </a:prstGeom>
+        </p:spPr>
+      </p:pic>
+    </p:spTree>
+    <p:extLst>
+      <p:ext uri="{BB962C8B-B14F-4D97-AF65-F5344CB8AC3E}">
+        <p14:creationId xmlns:p14="http://schemas.microsoft.com/office/powerpoint/2010/main" val="1345526751"/>
+      </p:ext>
+    </p:extLst>
+  </p:cSld>
+  <p:clrMapOvr>
+    <a:masterClrMapping/>
+  </p:clrMapOvr>
+</p:sld>
+</file>
+
+<file path=ppt/slides/slide8.xml><?xml version="1.0" encoding="utf-8"?>
+<p:sld xmlns:a="http://schemas.openxmlformats.org/drawingml/2006/main" xmlns:r="http://schemas.openxmlformats.org/officeDocument/2006/relationships" xmlns:p="http://schemas.openxmlformats.org/presentationml/2006/main">
+  <p:cSld>
+    <p:spTree>
+      <p:nvGrpSpPr>
+        <p:cNvPr id="1" name=""/>
+        <p:cNvGrpSpPr/>
+        <p:nvPr/>
+      </p:nvGrpSpPr>
+      <p:grpSpPr>
+        <a:xfrm>
+          <a:off x="0" y="0"/>
+          <a:ext cx="0" cy="0"/>
+          <a:chOff x="0" y="0"/>
+          <a:chExt cx="0" cy="0"/>
+        </a:xfrm>
+      </p:grpSpPr>
+      <p:sp>
+        <p:nvSpPr>
+          <p:cNvPr id="2" name="Cím 1"/>
+          <p:cNvSpPr>
+            <a:spLocks noGrp="1"/>
+          </p:cNvSpPr>
+          <p:nvPr>
+            <p:ph type="title"/>
+          </p:nvPr>
+        </p:nvSpPr>
+        <p:spPr/>
+        <p:txBody>
+          <a:bodyPr/>
+          <a:lstStyle/>
+          <a:p>
+            <a:r>
+              <a:rPr lang="hu-HU" dirty="0" smtClean="0"/>
+              <a:t>Profil</a:t>
+            </a:r>
+            <a:endParaRPr lang="hu-HU" dirty="0"/>
+          </a:p>
+        </p:txBody>
+      </p:sp>
+      <p:sp>
+        <p:nvSpPr>
+          <p:cNvPr id="3" name="Tartalom helye 2"/>
+          <p:cNvSpPr>
+            <a:spLocks noGrp="1"/>
+          </p:cNvSpPr>
+          <p:nvPr>
+            <p:ph idx="1"/>
+          </p:nvPr>
+        </p:nvSpPr>
+        <p:spPr/>
+        <p:txBody>
+          <a:bodyPr/>
+          <a:lstStyle/>
+          <a:p>
+            <a:r>
+              <a:rPr lang="hu-HU" dirty="0" smtClean="0"/>
+              <a:t>Ezen az oldalon törölhetjük, illetve szerkeszthetjük a saját </a:t>
+            </a:r>
+            <a:r>
+              <a:rPr lang="hu-HU" dirty="0" err="1" smtClean="0"/>
+              <a:t>szolgáltatásainket</a:t>
+            </a:r>
+            <a:r>
+              <a:rPr lang="hu-HU" dirty="0" smtClean="0"/>
+              <a:t>.</a:t>
+            </a:r>
+            <a:endParaRPr lang="hu-HU" dirty="0"/>
+          </a:p>
+        </p:txBody>
+      </p:sp>
+      <p:pic>
+        <p:nvPicPr>
+          <p:cNvPr id="4" name="Kép 3"/>
+          <p:cNvPicPr>
+            <a:picLocks noChangeAspect="1"/>
+          </p:cNvPicPr>
+          <p:nvPr/>
+        </p:nvPicPr>
+        <p:blipFill>
+          <a:blip r:embed="rId2"/>
+          <a:stretch>
+            <a:fillRect/>
+          </a:stretch>
+        </p:blipFill>
+        <p:spPr>
+          <a:xfrm>
+            <a:off x="775505" y="3576181"/>
+            <a:ext cx="3732836" cy="1943383"/>
+          </a:xfrm>
+          <a:prstGeom prst="rect">
+            <a:avLst/>
+          </a:prstGeom>
+        </p:spPr>
+      </p:pic>
+      <p:pic>
+        <p:nvPicPr>
+          <p:cNvPr id="5" name="Kép 4"/>
+          <p:cNvPicPr>
+            <a:picLocks noChangeAspect="1"/>
+          </p:cNvPicPr>
+          <p:nvPr/>
+        </p:nvPicPr>
+        <p:blipFill>
+          <a:blip r:embed="rId3"/>
+          <a:stretch>
+            <a:fillRect/>
+          </a:stretch>
+        </p:blipFill>
+        <p:spPr>
+          <a:xfrm>
+            <a:off x="7572762" y="3533792"/>
+            <a:ext cx="3759031" cy="1961744"/>
+          </a:xfrm>
+          <a:prstGeom prst="rect">
+            <a:avLst/>
+          </a:prstGeom>
+        </p:spPr>
+      </p:pic>
+      <p:pic>
+        <p:nvPicPr>
+          <p:cNvPr id="6" name="Kép 5"/>
+          <p:cNvPicPr>
+            <a:picLocks noChangeAspect="1"/>
+          </p:cNvPicPr>
+          <p:nvPr/>
+        </p:nvPicPr>
+        <p:blipFill>
+          <a:blip r:embed="rId4"/>
+          <a:stretch>
+            <a:fillRect/>
+          </a:stretch>
+        </p:blipFill>
+        <p:spPr>
+          <a:xfrm>
+            <a:off x="4616062" y="3368233"/>
+            <a:ext cx="2848979" cy="2292863"/>
+          </a:xfrm>
+          <a:prstGeom prst="rect">
+            <a:avLst/>
+          </a:prstGeom>
+        </p:spPr>
+      </p:pic>
+    </p:spTree>
+    <p:extLst>
+      <p:ext uri="{BB962C8B-B14F-4D97-AF65-F5344CB8AC3E}">
+        <p14:creationId xmlns:p14="http://schemas.microsoft.com/office/powerpoint/2010/main" val="1320157492"/>
+      </p:ext>
+    </p:extLst>
+  </p:cSld>
+  <p:clrMapOvr>
+    <a:masterClrMapping/>
+  </p:clrMapOvr>
+</p:sld>
+</file>
+
+<file path=ppt/slides/slide9.xml><?xml version="1.0" encoding="utf-8"?>
+<p:sld xmlns:a="http://schemas.openxmlformats.org/drawingml/2006/main" xmlns:r="http://schemas.openxmlformats.org/officeDocument/2006/relationships" xmlns:p="http://schemas.openxmlformats.org/presentationml/2006/main">
+  <p:cSld>
+    <p:spTree>
+      <p:nvGrpSpPr>
+        <p:cNvPr id="1" name=""/>
+        <p:cNvGrpSpPr/>
+        <p:nvPr/>
+      </p:nvGrpSpPr>
+      <p:grpSpPr>
+        <a:xfrm>
+          <a:off x="0" y="0"/>
+          <a:ext cx="0" cy="0"/>
+          <a:chOff x="0" y="0"/>
+          <a:chExt cx="0" cy="0"/>
+        </a:xfrm>
+      </p:grpSpPr>
+      <p:sp>
+        <p:nvSpPr>
+          <p:cNvPr id="2" name="Cím 1"/>
+          <p:cNvSpPr>
+            <a:spLocks noGrp="1"/>
+          </p:cNvSpPr>
+          <p:nvPr>
+            <p:ph type="title"/>
+          </p:nvPr>
+        </p:nvSpPr>
+        <p:spPr/>
+        <p:txBody>
+          <a:bodyPr/>
+          <a:lstStyle/>
+          <a:p>
+            <a:r>
+              <a:rPr lang="hu-HU" dirty="0" smtClean="0"/>
+              <a:t>Tranzakciók</a:t>
+            </a:r>
+            <a:endParaRPr lang="hu-HU" dirty="0"/>
+          </a:p>
+        </p:txBody>
+      </p:sp>
+      <p:sp>
+        <p:nvSpPr>
+          <p:cNvPr id="3" name="Tartalom helye 2"/>
+          <p:cNvSpPr>
+            <a:spLocks noGrp="1"/>
+          </p:cNvSpPr>
+          <p:nvPr>
+            <p:ph idx="1"/>
+          </p:nvPr>
+        </p:nvSpPr>
+        <p:spPr/>
+        <p:txBody>
+          <a:bodyPr/>
+          <a:lstStyle/>
+          <a:p>
+            <a:r>
+              <a:rPr lang="hu-HU" dirty="0" smtClean="0"/>
+              <a:t>Itt tekinthetjük meg az összes eddigi tranzakciókat. Legyen szó akár megvásárolt, vagy eladott szolgáltatásokról. Itt is láthatjuk a biztonsági kódunkat, mely segít az átverések minimalizálásában.</a:t>
+            </a:r>
+            <a:endParaRPr lang="hu-HU" dirty="0"/>
+          </a:p>
+        </p:txBody>
+      </p:sp>
+      <p:pic>
+        <p:nvPicPr>
+          <p:cNvPr id="5" name="Kép 4"/>
+          <p:cNvPicPr>
+            <a:picLocks noChangeAspect="1"/>
+          </p:cNvPicPr>
+          <p:nvPr/>
+        </p:nvPicPr>
+        <p:blipFill>
+          <a:blip r:embed="rId2"/>
+          <a:stretch>
+            <a:fillRect/>
+          </a:stretch>
+        </p:blipFill>
+        <p:spPr>
+          <a:xfrm>
+            <a:off x="2885774" y="3767559"/>
+            <a:ext cx="5600297" cy="2916821"/>
+          </a:xfrm>
+          <a:prstGeom prst="rect">
+            <a:avLst/>
+          </a:prstGeom>
+        </p:spPr>
+      </p:pic>
+    </p:spTree>
+    <p:extLst>
+      <p:ext uri="{BB962C8B-B14F-4D97-AF65-F5344CB8AC3E}">
+        <p14:creationId xmlns:p14="http://schemas.microsoft.com/office/powerpoint/2010/main" val="2591111221"/>
       </p:ext>
     </p:extLst>
   </p:cSld>

</xml_diff>